<commit_message>
Rename metrics variables and add cpu utilization of edge embedding.
</commit_message>
<xml_diff>
--- a/Records/Secure_Distributed_VLM_Experiment_Logic_EN.pptx
+++ b/Records/Secure_Distributed_VLM_Experiment_Logic_EN.pptx
@@ -1586,7 +1586,7 @@
           <a:bodyPr/>
           <a:lstStyle/>
           <a:p>
-            <a:endParaRPr/>
+            <a:endParaRPr dirty="0"/>
           </a:p>
         </p:txBody>
       </p:sp>
@@ -5378,7 +5378,7 @@
               </a:defRPr>
             </a:pPr>
             <a:r>
-              <a:rPr sz="1500" b="1">
+              <a:rPr sz="1500" b="1" dirty="0">
                 <a:solidFill>
                   <a:srgbClr val="555555"/>
                 </a:solidFill>
@@ -5428,7 +5428,7 @@
               </a:defRPr>
             </a:pPr>
             <a:r>
-              <a:rPr sz="1500" b="1">
+              <a:rPr sz="1500" b="1" dirty="0">
                 <a:solidFill>
                   <a:srgbClr val="555555"/>
                 </a:solidFill>
@@ -5478,7 +5478,7 @@
               </a:defRPr>
             </a:pPr>
             <a:r>
-              <a:rPr sz="1500" b="1">
+              <a:rPr sz="1500" b="1" dirty="0">
                 <a:solidFill>
                   <a:srgbClr val="555555"/>
                 </a:solidFill>
@@ -5975,7 +5975,7 @@
               </a:defRPr>
             </a:pPr>
             <a:r>
-              <a:rPr sz="1425" b="0">
+              <a:rPr sz="1425" b="0" dirty="0">
                 <a:solidFill>
                   <a:srgbClr val="000000"/>
                 </a:solidFill>
@@ -6215,7 +6215,7 @@
               </a:defRPr>
             </a:pPr>
             <a:r>
-              <a:rPr sz="1425" b="0">
+              <a:rPr sz="1425" b="0" dirty="0">
                 <a:solidFill>
                   <a:srgbClr val="000000"/>
                 </a:solidFill>
@@ -6265,7 +6265,7 @@
               </a:defRPr>
             </a:pPr>
             <a:r>
-              <a:rPr sz="1575" b="1">
+              <a:rPr sz="1575" b="1" dirty="0">
                 <a:solidFill>
                   <a:srgbClr val="000000"/>
                 </a:solidFill>
@@ -6315,7 +6315,7 @@
               </a:defRPr>
             </a:pPr>
             <a:r>
-              <a:rPr sz="1425" b="0">
+              <a:rPr sz="1425" b="0" dirty="0">
                 <a:solidFill>
                   <a:srgbClr val="000000"/>
                 </a:solidFill>
@@ -6415,7 +6415,7 @@
               </a:defRPr>
             </a:pPr>
             <a:r>
-              <a:rPr sz="1425" b="0">
+              <a:rPr sz="1425" b="0" dirty="0">
                 <a:solidFill>
                   <a:srgbClr val="000000"/>
                 </a:solidFill>
@@ -6653,7 +6653,7 @@
               </a:defRPr>
             </a:pPr>
             <a:r>
-              <a:rPr sz="2925" b="1">
+              <a:rPr sz="2925" b="1" dirty="0">
                 <a:solidFill>
                   <a:srgbClr val="000000"/>
                 </a:solidFill>
@@ -6743,7 +6743,7 @@
               </a:defRPr>
             </a:pPr>
             <a:r>
-              <a:rPr sz="2100" b="1">
+              <a:rPr sz="2100" b="1" dirty="0">
                 <a:solidFill>
                   <a:srgbClr val="000000"/>
                 </a:solidFill>
@@ -6883,7 +6883,7 @@
               </a:defRPr>
             </a:pPr>
             <a:r>
-              <a:rPr sz="1650" b="1">
+              <a:rPr sz="1650" b="1" dirty="0">
                 <a:solidFill>
                   <a:srgbClr val="000000"/>
                 </a:solidFill>
@@ -7107,7 +7107,7 @@
               </a:defRPr>
             </a:pPr>
             <a:r>
-              <a:rPr sz="1650" b="1">
+              <a:rPr sz="1650" b="1" dirty="0">
                 <a:solidFill>
                   <a:srgbClr val="FF6B35"/>
                 </a:solidFill>
@@ -7157,7 +7157,7 @@
               </a:defRPr>
             </a:pPr>
             <a:r>
-              <a:rPr sz="1350" b="0">
+              <a:rPr sz="1350" b="0" dirty="0">
                 <a:solidFill>
                   <a:srgbClr val="000000"/>
                 </a:solidFill>
@@ -7174,7 +7174,7 @@
               </a:defRPr>
             </a:pPr>
             <a:r>
-              <a:rPr sz="1350" b="0">
+              <a:rPr sz="1350" b="0" dirty="0">
                 <a:solidFill>
                   <a:srgbClr val="000000"/>
                 </a:solidFill>
@@ -7191,7 +7191,7 @@
               </a:defRPr>
             </a:pPr>
             <a:r>
-              <a:rPr sz="1350" b="0">
+              <a:rPr sz="1350" b="0" dirty="0">
                 <a:solidFill>
                   <a:srgbClr val="000000"/>
                 </a:solidFill>
@@ -7381,7 +7381,7 @@
               </a:defRPr>
             </a:pPr>
             <a:r>
-              <a:rPr sz="1350" b="0">
+              <a:rPr sz="1350" b="0" dirty="0">
                 <a:solidFill>
                   <a:srgbClr val="000000"/>
                 </a:solidFill>
@@ -7398,7 +7398,7 @@
               </a:defRPr>
             </a:pPr>
             <a:r>
-              <a:rPr sz="1350" b="0">
+              <a:rPr sz="1350" b="0" dirty="0">
                 <a:solidFill>
                   <a:srgbClr val="000000"/>
                 </a:solidFill>
@@ -7415,7 +7415,7 @@
               </a:defRPr>
             </a:pPr>
             <a:r>
-              <a:rPr sz="1350" b="0">
+              <a:rPr sz="1350" b="0" dirty="0">
                 <a:solidFill>
                   <a:srgbClr val="000000"/>
                 </a:solidFill>
@@ -7515,7 +7515,7 @@
               </a:defRPr>
             </a:pPr>
             <a:r>
-              <a:rPr sz="3600" b="1">
+              <a:rPr sz="3600" b="1" dirty="0">
                 <a:solidFill>
                   <a:srgbClr val="000000"/>
                 </a:solidFill>
@@ -7565,7 +7565,7 @@
               </a:defRPr>
             </a:pPr>
             <a:r>
-              <a:rPr sz="1350" b="0">
+              <a:rPr sz="1350" b="0" dirty="0">
                 <a:solidFill>
                   <a:srgbClr val="555555"/>
                 </a:solidFill>
@@ -7665,13 +7665,26 @@
               </a:defRPr>
             </a:pPr>
             <a:r>
-              <a:rPr sz="3600" b="1">
-                <a:solidFill>
-                  <a:srgbClr val="000000"/>
-                </a:solidFill>
-              </a:rPr>
-              <a:t>4-20 ms</a:t>
-            </a:r>
+              <a:rPr sz="3600" b="1" dirty="0">
+                <a:solidFill>
+                  <a:srgbClr val="000000"/>
+                </a:solidFill>
+              </a:rPr>
+              <a:t>4-20 </a:t>
+            </a:r>
+            <a:r>
+              <a:rPr sz="3600" b="1" dirty="0" err="1">
+                <a:solidFill>
+                  <a:srgbClr val="000000"/>
+                </a:solidFill>
+              </a:rPr>
+              <a:t>ms</a:t>
+            </a:r>
+            <a:endParaRPr sz="3600" b="1" dirty="0">
+              <a:solidFill>
+                <a:srgbClr val="000000"/>
+              </a:solidFill>
+            </a:endParaRPr>
           </a:p>
         </p:txBody>
       </p:sp>
@@ -7715,7 +7728,7 @@
               </a:defRPr>
             </a:pPr>
             <a:r>
-              <a:rPr sz="1350" b="0">
+              <a:rPr sz="1350" b="0" dirty="0">
                 <a:solidFill>
                   <a:srgbClr val="555555"/>
                 </a:solidFill>
@@ -7765,7 +7778,7 @@
               </a:defRPr>
             </a:pPr>
             <a:r>
-              <a:rPr sz="1200" b="1">
+              <a:rPr sz="1200" b="1" dirty="0">
                 <a:solidFill>
                   <a:srgbClr val="555555"/>
                 </a:solidFill>
@@ -7815,7 +7828,7 @@
               </a:defRPr>
             </a:pPr>
             <a:r>
-              <a:rPr sz="3600" b="1">
+              <a:rPr sz="3600" b="1" dirty="0">
                 <a:solidFill>
                   <a:srgbClr val="000000"/>
                 </a:solidFill>

</xml_diff>